<commit_message>
changes to power point
</commit_message>
<xml_diff>
--- a/researchers_guide_to_code_organization_day_1.pptx
+++ b/researchers_guide_to_code_organization_day_1.pptx
@@ -312,7 +312,7 @@
           <a:p>
             <a:fld id="{0852A73A-4261-AF44-B157-2572E11BF117}" type="datetimeFigureOut">
               <a:rPr lang="en-US" smtClean="0"/>
-              <a:t>3/3/26</a:t>
+              <a:t>3/4/26</a:t>
             </a:fld>
             <a:endParaRPr lang="en-US"/>
           </a:p>
@@ -1053,7 +1053,7 @@
           <a:p>
             <a:fld id="{21B0DD4A-49F6-694F-BA0E-D1F51DB36AFE}" type="datetimeFigureOut">
               <a:rPr lang="en-US" smtClean="0"/>
-              <a:t>3/3/26</a:t>
+              <a:t>3/4/26</a:t>
             </a:fld>
             <a:endParaRPr lang="en-US"/>
           </a:p>
@@ -1166,7 +1166,7 @@
           <a:p>
             <a:fld id="{21B0DD4A-49F6-694F-BA0E-D1F51DB36AFE}" type="datetimeFigureOut">
               <a:rPr lang="en-US" smtClean="0"/>
-              <a:t>3/3/26</a:t>
+              <a:t>3/4/26</a:t>
             </a:fld>
             <a:endParaRPr lang="en-US"/>
           </a:p>
@@ -1477,7 +1477,7 @@
           <a:p>
             <a:fld id="{21B0DD4A-49F6-694F-BA0E-D1F51DB36AFE}" type="datetimeFigureOut">
               <a:rPr lang="en-US" smtClean="0"/>
-              <a:t>3/3/26</a:t>
+              <a:t>3/4/26</a:t>
             </a:fld>
             <a:endParaRPr lang="en-US"/>
           </a:p>
@@ -1765,7 +1765,7 @@
           <a:p>
             <a:fld id="{21B0DD4A-49F6-694F-BA0E-D1F51DB36AFE}" type="datetimeFigureOut">
               <a:rPr lang="en-US" smtClean="0"/>
-              <a:t>3/3/26</a:t>
+              <a:t>3/4/26</a:t>
             </a:fld>
             <a:endParaRPr lang="en-US"/>
           </a:p>
@@ -1963,7 +1963,7 @@
           <a:p>
             <a:fld id="{21B0DD4A-49F6-694F-BA0E-D1F51DB36AFE}" type="datetimeFigureOut">
               <a:rPr lang="en-US" smtClean="0"/>
-              <a:t>3/3/26</a:t>
+              <a:t>3/4/26</a:t>
             </a:fld>
             <a:endParaRPr lang="en-US"/>
           </a:p>
@@ -2171,7 +2171,7 @@
           <a:p>
             <a:fld id="{21B0DD4A-49F6-694F-BA0E-D1F51DB36AFE}" type="datetimeFigureOut">
               <a:rPr lang="en-US" smtClean="0"/>
-              <a:t>3/3/26</a:t>
+              <a:t>3/4/26</a:t>
             </a:fld>
             <a:endParaRPr lang="en-US"/>
           </a:p>
@@ -2398,7 +2398,7 @@
           <a:p>
             <a:fld id="{0C56C575-D94E-F044-B574-12900C1740FB}" type="datetimeFigureOut">
               <a:rPr lang="en-US" smtClean="0"/>
-              <a:t>3/3/26</a:t>
+              <a:t>3/4/26</a:t>
             </a:fld>
             <a:endParaRPr lang="en-US"/>
           </a:p>
@@ -2646,7 +2646,7 @@
           <a:p>
             <a:fld id="{0C56C575-D94E-F044-B574-12900C1740FB}" type="datetimeFigureOut">
               <a:rPr lang="en-US" smtClean="0"/>
-              <a:t>3/3/26</a:t>
+              <a:t>3/4/26</a:t>
             </a:fld>
             <a:endParaRPr lang="en-US"/>
           </a:p>
@@ -2986,7 +2986,7 @@
           <a:p>
             <a:fld id="{0C56C575-D94E-F044-B574-12900C1740FB}" type="datetimeFigureOut">
               <a:rPr lang="en-US" smtClean="0"/>
-              <a:t>3/3/26</a:t>
+              <a:t>3/4/26</a:t>
             </a:fld>
             <a:endParaRPr lang="en-US"/>
           </a:p>
@@ -3252,7 +3252,7 @@
           <a:p>
             <a:fld id="{21B0DD4A-49F6-694F-BA0E-D1F51DB36AFE}" type="datetimeFigureOut">
               <a:rPr lang="en-US" smtClean="0"/>
-              <a:t>3/3/26</a:t>
+              <a:t>3/4/26</a:t>
             </a:fld>
             <a:endParaRPr lang="en-US"/>
           </a:p>
@@ -3527,7 +3527,7 @@
           <a:p>
             <a:fld id="{21B0DD4A-49F6-694F-BA0E-D1F51DB36AFE}" type="datetimeFigureOut">
               <a:rPr lang="en-US" smtClean="0"/>
-              <a:t>3/3/26</a:t>
+              <a:t>3/4/26</a:t>
             </a:fld>
             <a:endParaRPr lang="en-US"/>
           </a:p>
@@ -3792,7 +3792,7 @@
           <a:p>
             <a:fld id="{21B0DD4A-49F6-694F-BA0E-D1F51DB36AFE}" type="datetimeFigureOut">
               <a:rPr lang="en-US" smtClean="0"/>
-              <a:t>3/3/26</a:t>
+              <a:t>3/4/26</a:t>
             </a:fld>
             <a:endParaRPr lang="en-US"/>
           </a:p>
@@ -4204,7 +4204,7 @@
           <a:p>
             <a:fld id="{21B0DD4A-49F6-694F-BA0E-D1F51DB36AFE}" type="datetimeFigureOut">
               <a:rPr lang="en-US" smtClean="0"/>
-              <a:t>3/3/26</a:t>
+              <a:t>3/4/26</a:t>
             </a:fld>
             <a:endParaRPr lang="en-US"/>
           </a:p>
@@ -4345,7 +4345,7 @@
           <a:p>
             <a:fld id="{21B0DD4A-49F6-694F-BA0E-D1F51DB36AFE}" type="datetimeFigureOut">
               <a:rPr lang="en-US" smtClean="0"/>
-              <a:t>3/3/26</a:t>
+              <a:t>3/4/26</a:t>
             </a:fld>
             <a:endParaRPr lang="en-US"/>
           </a:p>
@@ -4586,7 +4586,7 @@
           <a:p>
             <a:fld id="{21B0DD4A-49F6-694F-BA0E-D1F51DB36AFE}" type="datetimeFigureOut">
               <a:rPr lang="en-US" smtClean="0"/>
-              <a:t>3/3/26</a:t>
+              <a:t>3/4/26</a:t>
             </a:fld>
             <a:endParaRPr lang="en-US"/>
           </a:p>

</xml_diff>